<commit_message>
Localize RAG documents to Vietnamese
</commit_message>
<xml_diff>
--- a/sample_documents/it_security_guide.pptx
+++ b/sample_documents/it_security_guide.pptx
@@ -3106,7 +3106,7 @@
           <a:lstStyle/>
           <a:p>
             <a:r>
-              <a:t>Enterprise IT Security &amp; Remote Work Policy</a:t>
+              <a:t>Chính sách bảo mật CNTT và làm việc từ xa</a:t>
             </a:r>
           </a:p>
         </p:txBody>
@@ -3127,7 +3127,7 @@
           <a:lstStyle/>
           <a:p>
             <a:r>
-              <a:t>Guidelines for Secure Operations</a:t>
+              <a:t>Hướng dẫn vận hành an toàn</a:t>
             </a:r>
           </a:p>
         </p:txBody>
@@ -3166,7 +3166,7 @@
           <a:lstStyle/>
           <a:p>
             <a:r>
-              <a:t>VPN &amp; Remote Connection Rules</a:t>
+              <a:t>Quy định VPN và kết nối từ xa</a:t>
             </a:r>
           </a:p>
         </p:txBody>
@@ -3187,17 +3187,17 @@
           <a:lstStyle/>
           <a:p>
             <a:r>
-              <a:t>Always use the official Corporate Cisco VPN client when working remotely.</a:t>
-            </a:r>
-          </a:p>
-          <a:p>
-            <a:r>
-              <a:t>Never connect to corporate resources from public Wi-Fi networks (e.g. coffee shops) without VPN enabled.</a:t>
-            </a:r>
-          </a:p>
-          <a:p>
-            <a:r>
-              <a:t>Multi-factor authentication (MFA) via Duo Security is mandatory for all VPN connections.</a:t>
+              <a:t>Luôn sử dụng ứng dụng Cisco VPN chính thức của công ty khi làm việc từ xa.</a:t>
+            </a:r>
+          </a:p>
+          <a:p>
+            <a:r>
+              <a:t>Không truy cập tài nguyên công ty từ Wi-Fi công cộng nếu chưa bật VPN.</a:t>
+            </a:r>
+          </a:p>
+          <a:p>
+            <a:r>
+              <a:t>Xác thực đa yếu tố (MFA) qua Duo Security là bắt buộc cho mọi kết nối VPN.</a:t>
             </a:r>
           </a:p>
         </p:txBody>
@@ -3236,7 +3236,7 @@
           <a:lstStyle/>
           <a:p>
             <a:r>
-              <a:t>Password Complexity Guidelines</a:t>
+              <a:t>Yêu cầu độ mạnh mật khẩu</a:t>
             </a:r>
           </a:p>
         </p:txBody>
@@ -3257,17 +3257,17 @@
           <a:lstStyle/>
           <a:p>
             <a:r>
-              <a:t>Passwords must be at least 12 characters in length.</a:t>
-            </a:r>
-          </a:p>
-          <a:p>
-            <a:r>
-              <a:t>Must contain uppercase letters, lowercase letters, numbers, and special symbols (e.g., !, @, #).</a:t>
-            </a:r>
-          </a:p>
-          <a:p>
-            <a:r>
-              <a:t>Passwords must be rotated every 90 days. Avoid reusing the last 5 passwords.</a:t>
+              <a:t>Mật khẩu phải có tối thiểu 12 ký tự.</a:t>
+            </a:r>
+          </a:p>
+          <a:p>
+            <a:r>
+              <a:t>Mật khẩu phải có chữ hoa, chữ thường, chữ số và ký tự đặc biệt như !, @, #.</a:t>
+            </a:r>
+          </a:p>
+          <a:p>
+            <a:r>
+              <a:t>Mật khẩu phải được thay đổi mỗi 90 ngày và không được dùng lại 5 mật khẩu gần nhất.</a:t>
             </a:r>
           </a:p>
         </p:txBody>

</xml_diff>